<commit_message>
Frame the debugging write-up around where the AI got it wrong
The brief asks candidates to come ready to discuss where their AI tooling
produced something wrong. Both bugs here are exactly that: Claude wrote the
code, wrote tests that passed against it, and was wrong anyway. Reframed the
README and slide 4 to say so, and to name what the failures have in common --
one spans two findings, the other rests on an assumption about model behaviour
that is invisible in the source.

Generated with Claude Code (https://claude.com/claude-code)
Co-Authored-By: Claude <noreply@anthropic.com>
</commit_message>
<xml_diff>
--- a/docs/Zycus_Redlining_Agent_Deck.pptx
+++ b/docs/Zycus_Redlining_Agent_Deck.pptx
@@ -5234,7 +5234,7 @@
                 </a:solidFill>
                 <a:latin typeface="Consolas"/>
               </a:rPr>
-              <a:t>04   WHAT BROKE</a:t>
+              <a:t>04   WHERE THE AI GOT IT WRONG</a:t>
             </a:r>
           </a:p>
         </p:txBody>
@@ -5273,7 +5273,7 @@
                 </a:solidFill>
                 <a:latin typeface="Georgia"/>
               </a:rPr>
-              <a:t>Two bugs the tests were happy with</a:t>
+              <a:t>Two bugs Claude wrote, and its own tests passed</a:t>
             </a:r>
           </a:p>
         </p:txBody>
@@ -5312,7 +5312,7 @@
                 </a:solidFill>
                 <a:latin typeface="Segoe UI"/>
               </a:rPr>
-              <a:t>Both were found by reading the output, not by a crash. Neither would have been caught by asking “does it return findings?”</a:t>
+              <a:t>Every module here was AI-generated. Both bugs survived review and a green test suite, and were caught only by reading the product output against the sample contract.</a:t>
             </a:r>
           </a:p>
         </p:txBody>
@@ -5351,7 +5351,7 @@
                 </a:solidFill>
                 <a:latin typeface="Consolas"/>
               </a:rPr>
-              <a:t>BUG 1  ·  SILENT DATA LOSS</a:t>
+              <a:t>BUG 1  ·  CORRECT IN EACH PART, WRONG AS A WHOLE</a:t>
             </a:r>
           </a:p>
         </p:txBody>
@@ -5430,7 +5430,7 @@
                 </a:solidFill>
                 <a:latin typeface="Segoe UI"/>
               </a:rPr>
-              <a:t>Clause 1 breaches two rules at once. Drafting ran per clause-rule pair, so each replacement rewrote the whole clause and kept the other breach:</a:t>
+              <a:t>Clause 1 breaches two rules at once. Claude drafted per clause-rule pair, which reads sensibly one function at a time, and kept the other breach each time:</a:t>
             </a:r>
           </a:p>
         </p:txBody>
@@ -5793,7 +5793,7 @@
                 </a:solidFill>
                 <a:latin typeface="Segoe UI"/>
               </a:rPr>
-              <a:t>Paste either one and you fix a violation while shipping the other. Every unit test passed throughout, because each redline was individually correct.</a:t>
+              <a:t>Paste either one and you fix a violation while shipping the other. Every test passed: the bug lives only in the relationship between two findings.</a:t>
             </a:r>
           </a:p>
         </p:txBody>
@@ -5994,7 +5994,7 @@
                 </a:solidFill>
                 <a:latin typeface="Consolas"/>
               </a:rPr>
-              <a:t>BUG 2  ·  A FEATURE THAT NEVER FIRED</a:t>
+              <a:t>BUG 2  ·  RIGHT CODE, WRONG ASSUMPTION</a:t>
             </a:r>
           </a:p>
         </p:txBody>
@@ -6073,7 +6073,7 @@
                 </a:solidFill>
                 <a:latin typeface="Segoe UI"/>
               </a:rPr>
-              <a:t>The low-confidence branch never triggered. Against a deliberately vague draft the model reported:</a:t>
+              <a:t>Asked for confidence handling, Claude let the model score itself and thresholded on it. It never fired once. Against a deliberately vague draft:</a:t>
             </a:r>
           </a:p>
         </p:txBody>
@@ -6748,7 +6748,7 @@
                 </a:solidFill>
                 <a:latin typeface="Segoe UI"/>
               </a:rPr>
-              <a:t>Confidence sat at 0.8–0.9 however little the clause committed to. The last row is the dangerous one: a clause naming no jurisdiction at all, confidently cleared.</a:t>
+              <a:t>Confidence sat at 0.8–0.9 however little the clause committed to. The code was not buggy; the wrong assumption was about model behaviour.</a:t>
             </a:r>
           </a:p>
         </p:txBody>

</xml_diff>

<commit_message>
Regenerate the deck against the current product
The deck had drifted badly. Every screenshot predated the app shell, sidebar,
dark theme and filters, so it showed an interface that no longer exists, and it
claimed 86 tests when there are 132. It also never mentioned upload,
persistence, review history or custom playbooks. Submitting it alongside a live
link would have shown an interviewer two different products.

Fresh screenshots driven from the running app, current numbers, and the
swappable playbook noted where it fits. Slide 3 now leads with the whole
application in one frame rather than two stacked strips.

Verified by exporting every slide through PowerPoint: the flagged card grew
taller than the one it replaced and was overlapping its caption, and stacking a
second screenshot under the full-app shot ran off the page. Both corrected.

Generated with Claude Code (https://claude.com/claude-code)
Co-Authored-By: Claude <noreply@anthropic.com>
</commit_message>
<xml_diff>
--- a/docs/Zycus_Redlining_Agent_Deck.pptx
+++ b/docs/Zycus_Redlining_Agent_Deck.pptx
@@ -4417,8 +4417,8 @@
         </p:nvSpPr>
         <p:spPr>
           <a:xfrm>
-            <a:off x="658368" y="5010912"/>
-            <a:ext cx="10874959" cy="658368"/>
+            <a:off x="658368" y="4992624"/>
+            <a:ext cx="10874959" cy="969264"/>
           </a:xfrm>
           <a:prstGeom prst="rect">
             <a:avLst/>
@@ -4459,8 +4459,8 @@
         </p:nvSpPr>
         <p:spPr>
           <a:xfrm>
-            <a:off x="658368" y="5010912"/>
-            <a:ext cx="36576" cy="658368"/>
+            <a:off x="658368" y="4992624"/>
+            <a:ext cx="36576" cy="969264"/>
           </a:xfrm>
           <a:prstGeom prst="rect">
             <a:avLst/>
@@ -4501,8 +4501,8 @@
         </p:nvSpPr>
         <p:spPr>
           <a:xfrm>
-            <a:off x="859536" y="5148072"/>
-            <a:ext cx="10417759" cy="457200"/>
+            <a:off x="859536" y="5129784"/>
+            <a:ext cx="10417759" cy="777240"/>
           </a:xfrm>
           <a:prstGeom prst="rect">
             <a:avLst/>
@@ -4527,7 +4527,7 @@
                 </a:solidFill>
                 <a:latin typeface="Segoe UI"/>
               </a:rPr>
-              <a:t>Four of these rules turn on a number, so they can be settled by arithmetic. Three turn on what the words mean, and only those need a model. The system is built around that split.</a:t>
+              <a:t>Four of these rules turn on a number, so they can be settled by arithmetic. Three turn on what the words mean, and only those need a model. The system is built around that split, and it survives swapping the playbook: rules load as structured data carrying their own thresholds and anchor phrases, so a customer's own rules still reach the verified tier.</a:t>
             </a:r>
           </a:p>
         </p:txBody>
@@ -5010,7 +5010,7 @@
       </p:sp>
       <p:pic>
         <p:nvPicPr>
-          <p:cNvPr id="5" name="Picture 4" descr="shot-summary.png"/>
+          <p:cNvPr id="5" name="Picture 4" descr="new-shell.png"/>
           <p:cNvPicPr>
             <a:picLocks noChangeAspect="1"/>
           </p:cNvPicPr>
@@ -5024,8 +5024,8 @@
         </p:blipFill>
         <p:spPr>
           <a:xfrm>
-            <a:off x="658368" y="1920240"/>
-            <a:ext cx="10874959" cy="1633351"/>
+            <a:off x="658368" y="1847088"/>
+            <a:ext cx="7223760" cy="4526890"/>
           </a:xfrm>
           <a:prstGeom prst="rect">
             <a:avLst/>
@@ -5040,8 +5040,8 @@
         </p:nvSpPr>
         <p:spPr>
           <a:xfrm>
-            <a:off x="658368" y="3675887"/>
-            <a:ext cx="10874959" cy="201168"/>
+            <a:off x="8202168" y="1874519"/>
+            <a:ext cx="3331159" cy="228600"/>
           </a:xfrm>
           <a:prstGeom prst="rect">
             <a:avLst/>
@@ -5060,116 +5060,544 @@
               </a:lnSpc>
             </a:pPr>
             <a:r>
-              <a:rPr sz="1050" b="0" i="1">
+              <a:rPr sz="1200" b="1" i="0">
+                <a:solidFill>
+                  <a:srgbClr val="16202E"/>
+                </a:solidFill>
+                <a:latin typeface="Segoe UI"/>
+              </a:rPr>
+              <a:t>Everything in one frame</a:t>
+            </a:r>
+          </a:p>
+        </p:txBody>
+      </p:sp>
+      <p:sp>
+        <p:nvSpPr>
+          <p:cNvPr id="7" name="Rectangle 6"/>
+          <p:cNvSpPr/>
+          <p:nvPr/>
+        </p:nvSpPr>
+        <p:spPr>
+          <a:xfrm>
+            <a:off x="8202168" y="2240280"/>
+            <a:ext cx="3331159" cy="768096"/>
+          </a:xfrm>
+          <a:prstGeom prst="rect">
+            <a:avLst/>
+          </a:prstGeom>
+          <a:solidFill>
+            <a:srgbClr val="F5F7FA"/>
+          </a:solidFill>
+          <a:ln>
+            <a:noFill/>
+          </a:ln>
+          <a:effectLst/>
+        </p:spPr>
+        <p:style>
+          <a:lnRef idx="1">
+            <a:schemeClr val="accent1"/>
+          </a:lnRef>
+          <a:fillRef idx="3">
+            <a:schemeClr val="accent1"/>
+          </a:fillRef>
+          <a:effectRef idx="2">
+            <a:schemeClr val="accent1"/>
+          </a:effectRef>
+          <a:fontRef idx="minor">
+            <a:schemeClr val="lt1"/>
+          </a:fontRef>
+        </p:style>
+        <p:txBody>
+          <a:bodyPr rtlCol="0" anchor="ctr"/>
+          <a:lstStyle/>
+          <a:p/>
+        </p:txBody>
+      </p:sp>
+      <p:sp>
+        <p:nvSpPr>
+          <p:cNvPr id="8" name="Rectangle 7"/>
+          <p:cNvSpPr/>
+          <p:nvPr/>
+        </p:nvSpPr>
+        <p:spPr>
+          <a:xfrm>
+            <a:off x="8202168" y="2240280"/>
+            <a:ext cx="27432" cy="768096"/>
+          </a:xfrm>
+          <a:prstGeom prst="rect">
+            <a:avLst/>
+          </a:prstGeom>
+          <a:solidFill>
+            <a:srgbClr val="1F5FD6"/>
+          </a:solidFill>
+          <a:ln>
+            <a:noFill/>
+          </a:ln>
+          <a:effectLst/>
+        </p:spPr>
+        <p:style>
+          <a:lnRef idx="1">
+            <a:schemeClr val="accent1"/>
+          </a:lnRef>
+          <a:fillRef idx="3">
+            <a:schemeClr val="accent1"/>
+          </a:fillRef>
+          <a:effectRef idx="2">
+            <a:schemeClr val="accent1"/>
+          </a:effectRef>
+          <a:fontRef idx="minor">
+            <a:schemeClr val="lt1"/>
+          </a:fontRef>
+        </p:style>
+        <p:txBody>
+          <a:bodyPr rtlCol="0" anchor="ctr"/>
+          <a:lstStyle/>
+          <a:p/>
+        </p:txBody>
+      </p:sp>
+      <p:sp>
+        <p:nvSpPr>
+          <p:cNvPr id="9" name="TextBox 8"/>
+          <p:cNvSpPr txBox="1"/>
+          <p:nvPr/>
+        </p:nvSpPr>
+        <p:spPr>
+          <a:xfrm>
+            <a:off x="8348472" y="2359152"/>
+            <a:ext cx="3038551" cy="566928"/>
+          </a:xfrm>
+          <a:prstGeom prst="rect">
+            <a:avLst/>
+          </a:prstGeom>
+          <a:noFill/>
+        </p:spPr>
+        <p:txBody>
+          <a:bodyPr wrap="square" lIns="0" rIns="0" tIns="0" bIns="0">
+            <a:spAutoFit/>
+          </a:bodyPr>
+          <a:lstStyle/>
+          <a:p>
+            <a:pPr algn="l">
+              <a:lnSpc>
+                <a:spcPct val="125000"/>
+              </a:lnSpc>
+            </a:pPr>
+            <a:r>
+              <a:rPr sz="1050" b="0" i="0">
+                <a:solidFill>
+                  <a:srgbClr val="4A5668"/>
+                </a:solidFill>
+                <a:latin typeface="Segoe UI"/>
+              </a:rPr>
+              <a:t>A real PDF read into the editor, shown before any model call is spent on it.</a:t>
+            </a:r>
+          </a:p>
+        </p:txBody>
+      </p:sp>
+      <p:sp>
+        <p:nvSpPr>
+          <p:cNvPr id="10" name="Rectangle 9"/>
+          <p:cNvSpPr/>
+          <p:nvPr/>
+        </p:nvSpPr>
+        <p:spPr>
+          <a:xfrm>
+            <a:off x="8202168" y="3108960"/>
+            <a:ext cx="3331159" cy="768096"/>
+          </a:xfrm>
+          <a:prstGeom prst="rect">
+            <a:avLst/>
+          </a:prstGeom>
+          <a:solidFill>
+            <a:srgbClr val="F5F7FA"/>
+          </a:solidFill>
+          <a:ln>
+            <a:noFill/>
+          </a:ln>
+          <a:effectLst/>
+        </p:spPr>
+        <p:style>
+          <a:lnRef idx="1">
+            <a:schemeClr val="accent1"/>
+          </a:lnRef>
+          <a:fillRef idx="3">
+            <a:schemeClr val="accent1"/>
+          </a:fillRef>
+          <a:effectRef idx="2">
+            <a:schemeClr val="accent1"/>
+          </a:effectRef>
+          <a:fontRef idx="minor">
+            <a:schemeClr val="lt1"/>
+          </a:fontRef>
+        </p:style>
+        <p:txBody>
+          <a:bodyPr rtlCol="0" anchor="ctr"/>
+          <a:lstStyle/>
+          <a:p/>
+        </p:txBody>
+      </p:sp>
+      <p:sp>
+        <p:nvSpPr>
+          <p:cNvPr id="11" name="Rectangle 10"/>
+          <p:cNvSpPr/>
+          <p:nvPr/>
+        </p:nvSpPr>
+        <p:spPr>
+          <a:xfrm>
+            <a:off x="8202168" y="3108960"/>
+            <a:ext cx="27432" cy="768096"/>
+          </a:xfrm>
+          <a:prstGeom prst="rect">
+            <a:avLst/>
+          </a:prstGeom>
+          <a:solidFill>
+            <a:srgbClr val="1F5FD6"/>
+          </a:solidFill>
+          <a:ln>
+            <a:noFill/>
+          </a:ln>
+          <a:effectLst/>
+        </p:spPr>
+        <p:style>
+          <a:lnRef idx="1">
+            <a:schemeClr val="accent1"/>
+          </a:lnRef>
+          <a:fillRef idx="3">
+            <a:schemeClr val="accent1"/>
+          </a:fillRef>
+          <a:effectRef idx="2">
+            <a:schemeClr val="accent1"/>
+          </a:effectRef>
+          <a:fontRef idx="minor">
+            <a:schemeClr val="lt1"/>
+          </a:fontRef>
+        </p:style>
+        <p:txBody>
+          <a:bodyPr rtlCol="0" anchor="ctr"/>
+          <a:lstStyle/>
+          <a:p/>
+        </p:txBody>
+      </p:sp>
+      <p:sp>
+        <p:nvSpPr>
+          <p:cNvPr id="12" name="TextBox 11"/>
+          <p:cNvSpPr txBox="1"/>
+          <p:nvPr/>
+        </p:nvSpPr>
+        <p:spPr>
+          <a:xfrm>
+            <a:off x="8348472" y="3227832"/>
+            <a:ext cx="3038551" cy="566928"/>
+          </a:xfrm>
+          <a:prstGeom prst="rect">
+            <a:avLst/>
+          </a:prstGeom>
+          <a:noFill/>
+        </p:spPr>
+        <p:txBody>
+          <a:bodyPr wrap="square" lIns="0" rIns="0" tIns="0" bIns="0">
+            <a:spAutoFit/>
+          </a:bodyPr>
+          <a:lstStyle/>
+          <a:p>
+            <a:pPr algn="l">
+              <a:lnSpc>
+                <a:spcPct val="125000"/>
+              </a:lnSpc>
+            </a:pPr>
+            <a:r>
+              <a:rPr sz="1050" b="0" i="0">
+                <a:solidFill>
+                  <a:srgbClr val="4A5668"/>
+                </a:solidFill>
+                <a:latin typeface="Segoe UI"/>
+              </a:rPr>
+              <a:t>The playbook and the audit trail in the rail.</a:t>
+            </a:r>
+          </a:p>
+        </p:txBody>
+      </p:sp>
+      <p:sp>
+        <p:nvSpPr>
+          <p:cNvPr id="13" name="Rectangle 12"/>
+          <p:cNvSpPr/>
+          <p:nvPr/>
+        </p:nvSpPr>
+        <p:spPr>
+          <a:xfrm>
+            <a:off x="8202168" y="3977639"/>
+            <a:ext cx="3331159" cy="768096"/>
+          </a:xfrm>
+          <a:prstGeom prst="rect">
+            <a:avLst/>
+          </a:prstGeom>
+          <a:solidFill>
+            <a:srgbClr val="F5F7FA"/>
+          </a:solidFill>
+          <a:ln>
+            <a:noFill/>
+          </a:ln>
+          <a:effectLst/>
+        </p:spPr>
+        <p:style>
+          <a:lnRef idx="1">
+            <a:schemeClr val="accent1"/>
+          </a:lnRef>
+          <a:fillRef idx="3">
+            <a:schemeClr val="accent1"/>
+          </a:fillRef>
+          <a:effectRef idx="2">
+            <a:schemeClr val="accent1"/>
+          </a:effectRef>
+          <a:fontRef idx="minor">
+            <a:schemeClr val="lt1"/>
+          </a:fontRef>
+        </p:style>
+        <p:txBody>
+          <a:bodyPr rtlCol="0" anchor="ctr"/>
+          <a:lstStyle/>
+          <a:p/>
+        </p:txBody>
+      </p:sp>
+      <p:sp>
+        <p:nvSpPr>
+          <p:cNvPr id="14" name="Rectangle 13"/>
+          <p:cNvSpPr/>
+          <p:nvPr/>
+        </p:nvSpPr>
+        <p:spPr>
+          <a:xfrm>
+            <a:off x="8202168" y="3977639"/>
+            <a:ext cx="27432" cy="768096"/>
+          </a:xfrm>
+          <a:prstGeom prst="rect">
+            <a:avLst/>
+          </a:prstGeom>
+          <a:solidFill>
+            <a:srgbClr val="1F5FD6"/>
+          </a:solidFill>
+          <a:ln>
+            <a:noFill/>
+          </a:ln>
+          <a:effectLst/>
+        </p:spPr>
+        <p:style>
+          <a:lnRef idx="1">
+            <a:schemeClr val="accent1"/>
+          </a:lnRef>
+          <a:fillRef idx="3">
+            <a:schemeClr val="accent1"/>
+          </a:fillRef>
+          <a:effectRef idx="2">
+            <a:schemeClr val="accent1"/>
+          </a:effectRef>
+          <a:fontRef idx="minor">
+            <a:schemeClr val="lt1"/>
+          </a:fontRef>
+        </p:style>
+        <p:txBody>
+          <a:bodyPr rtlCol="0" anchor="ctr"/>
+          <a:lstStyle/>
+          <a:p/>
+        </p:txBody>
+      </p:sp>
+      <p:sp>
+        <p:nvSpPr>
+          <p:cNvPr id="15" name="TextBox 14"/>
+          <p:cNvSpPr txBox="1"/>
+          <p:nvPr/>
+        </p:nvSpPr>
+        <p:spPr>
+          <a:xfrm>
+            <a:off x="8348472" y="4096511"/>
+            <a:ext cx="3038551" cy="566928"/>
+          </a:xfrm>
+          <a:prstGeom prst="rect">
+            <a:avLst/>
+          </a:prstGeom>
+          <a:noFill/>
+        </p:spPr>
+        <p:txBody>
+          <a:bodyPr wrap="square" lIns="0" rIns="0" tIns="0" bIns="0">
+            <a:spAutoFit/>
+          </a:bodyPr>
+          <a:lstStyle/>
+          <a:p>
+            <a:pPr algn="l">
+              <a:lnSpc>
+                <a:spcPct val="125000"/>
+              </a:lnSpc>
+            </a:pPr>
+            <a:r>
+              <a:rPr sz="1050" b="0" i="0">
+                <a:solidFill>
+                  <a:srgbClr val="4A5668"/>
+                </a:solidFill>
+                <a:latin typeface="Segoe UI"/>
+              </a:rPr>
+              <a:t>The whole contract summarised before any scrolling.</a:t>
+            </a:r>
+          </a:p>
+        </p:txBody>
+      </p:sp>
+      <p:sp>
+        <p:nvSpPr>
+          <p:cNvPr id="16" name="Rectangle 15"/>
+          <p:cNvSpPr/>
+          <p:nvPr/>
+        </p:nvSpPr>
+        <p:spPr>
+          <a:xfrm>
+            <a:off x="8202168" y="4846320"/>
+            <a:ext cx="3331159" cy="768096"/>
+          </a:xfrm>
+          <a:prstGeom prst="rect">
+            <a:avLst/>
+          </a:prstGeom>
+          <a:solidFill>
+            <a:srgbClr val="F5F7FA"/>
+          </a:solidFill>
+          <a:ln>
+            <a:noFill/>
+          </a:ln>
+          <a:effectLst/>
+        </p:spPr>
+        <p:style>
+          <a:lnRef idx="1">
+            <a:schemeClr val="accent1"/>
+          </a:lnRef>
+          <a:fillRef idx="3">
+            <a:schemeClr val="accent1"/>
+          </a:fillRef>
+          <a:effectRef idx="2">
+            <a:schemeClr val="accent1"/>
+          </a:effectRef>
+          <a:fontRef idx="minor">
+            <a:schemeClr val="lt1"/>
+          </a:fontRef>
+        </p:style>
+        <p:txBody>
+          <a:bodyPr rtlCol="0" anchor="ctr"/>
+          <a:lstStyle/>
+          <a:p/>
+        </p:txBody>
+      </p:sp>
+      <p:sp>
+        <p:nvSpPr>
+          <p:cNvPr id="17" name="Rectangle 16"/>
+          <p:cNvSpPr/>
+          <p:nvPr/>
+        </p:nvSpPr>
+        <p:spPr>
+          <a:xfrm>
+            <a:off x="8202168" y="4846320"/>
+            <a:ext cx="27432" cy="768096"/>
+          </a:xfrm>
+          <a:prstGeom prst="rect">
+            <a:avLst/>
+          </a:prstGeom>
+          <a:solidFill>
+            <a:srgbClr val="1F5FD6"/>
+          </a:solidFill>
+          <a:ln>
+            <a:noFill/>
+          </a:ln>
+          <a:effectLst/>
+        </p:spPr>
+        <p:style>
+          <a:lnRef idx="1">
+            <a:schemeClr val="accent1"/>
+          </a:lnRef>
+          <a:fillRef idx="3">
+            <a:schemeClr val="accent1"/>
+          </a:fillRef>
+          <a:effectRef idx="2">
+            <a:schemeClr val="accent1"/>
+          </a:effectRef>
+          <a:fontRef idx="minor">
+            <a:schemeClr val="lt1"/>
+          </a:fontRef>
+        </p:style>
+        <p:txBody>
+          <a:bodyPr rtlCol="0" anchor="ctr"/>
+          <a:lstStyle/>
+          <a:p/>
+        </p:txBody>
+      </p:sp>
+      <p:sp>
+        <p:nvSpPr>
+          <p:cNvPr id="18" name="TextBox 17"/>
+          <p:cNvSpPr txBox="1"/>
+          <p:nvPr/>
+        </p:nvSpPr>
+        <p:spPr>
+          <a:xfrm>
+            <a:off x="8348472" y="4965192"/>
+            <a:ext cx="3038551" cy="566928"/>
+          </a:xfrm>
+          <a:prstGeom prst="rect">
+            <a:avLst/>
+          </a:prstGeom>
+          <a:noFill/>
+        </p:spPr>
+        <p:txBody>
+          <a:bodyPr wrap="square" lIns="0" rIns="0" tIns="0" bIns="0">
+            <a:spAutoFit/>
+          </a:bodyPr>
+          <a:lstStyle/>
+          <a:p>
+            <a:pPr algn="l">
+              <a:lnSpc>
+                <a:spcPct val="125000"/>
+              </a:lnSpc>
+            </a:pPr>
+            <a:r>
+              <a:rPr sz="1050" b="0" i="0">
+                <a:solidFill>
+                  <a:srgbClr val="4A5668"/>
+                </a:solidFill>
+                <a:latin typeface="Segoe UI"/>
+              </a:rPr>
+              <a:t>Findings filtered to what needs a human, or what to escalate.</a:t>
+            </a:r>
+          </a:p>
+        </p:txBody>
+      </p:sp>
+      <p:sp>
+        <p:nvSpPr>
+          <p:cNvPr id="19" name="TextBox 18"/>
+          <p:cNvSpPr txBox="1"/>
+          <p:nvPr/>
+        </p:nvSpPr>
+        <p:spPr>
+          <a:xfrm>
+            <a:off x="658368" y="6455664"/>
+            <a:ext cx="7223760" cy="256032"/>
+          </a:xfrm>
+          <a:prstGeom prst="rect">
+            <a:avLst/>
+          </a:prstGeom>
+          <a:noFill/>
+        </p:spPr>
+        <p:txBody>
+          <a:bodyPr wrap="square" lIns="0" rIns="0" tIns="0" bIns="0">
+            <a:spAutoFit/>
+          </a:bodyPr>
+          <a:lstStyle/>
+          <a:p>
+            <a:pPr algn="l">
+              <a:lnSpc>
+                <a:spcPct val="120000"/>
+              </a:lnSpc>
+            </a:pPr>
+            <a:r>
+              <a:rPr sz="1000" b="0" i="1">
                 <a:solidFill>
                   <a:srgbClr val="6D7888"/>
                 </a:solidFill>
                 <a:latin typeface="Segoe UI"/>
               </a:rPr>
-              <a:t>The whole contract in one line, before any scrolling.</a:t>
-            </a:r>
-          </a:p>
-        </p:txBody>
-      </p:sp>
-      <p:pic>
-        <p:nvPicPr>
-          <p:cNvPr id="7" name="Picture 6" descr="shot-verified.png"/>
-          <p:cNvPicPr>
-            <a:picLocks noChangeAspect="1"/>
-          </p:cNvPicPr>
-          <p:nvPr/>
-        </p:nvPicPr>
-        <p:blipFill>
-          <a:blip r:embed="rId3"/>
-          <a:stretch>
-            <a:fillRect/>
-          </a:stretch>
-        </p:blipFill>
-        <p:spPr>
-          <a:xfrm>
-            <a:off x="658368" y="4069080"/>
-            <a:ext cx="7315200" cy="2466753"/>
-          </a:xfrm>
-          <a:prstGeom prst="rect">
-            <a:avLst/>
-          </a:prstGeom>
-        </p:spPr>
-      </p:pic>
-      <p:sp>
-        <p:nvSpPr>
-          <p:cNvPr id="8" name="TextBox 7"/>
-          <p:cNvSpPr txBox="1"/>
-          <p:nvPr/>
-        </p:nvSpPr>
-        <p:spPr>
-          <a:xfrm>
-            <a:off x="8339328" y="4114800"/>
-            <a:ext cx="3193999" cy="228600"/>
-          </a:xfrm>
-          <a:prstGeom prst="rect">
-            <a:avLst/>
-          </a:prstGeom>
-          <a:noFill/>
-        </p:spPr>
-        <p:txBody>
-          <a:bodyPr wrap="square" lIns="0" rIns="0" tIns="0" bIns="0">
-            <a:spAutoFit/>
-          </a:bodyPr>
-          <a:lstStyle/>
-          <a:p>
-            <a:pPr algn="l">
-              <a:lnSpc>
-                <a:spcPct val="120000"/>
-              </a:lnSpc>
-            </a:pPr>
-            <a:r>
-              <a:rPr sz="1200" b="1" i="0">
-                <a:solidFill>
-                  <a:srgbClr val="16202E"/>
-                </a:solidFill>
-                <a:latin typeface="Segoe UI"/>
-              </a:rPr>
-              <a:t>One finding, end to end</a:t>
-            </a:r>
-          </a:p>
-        </p:txBody>
-      </p:sp>
-      <p:sp>
-        <p:nvSpPr>
-          <p:cNvPr id="9" name="TextBox 8"/>
-          <p:cNvSpPr txBox="1"/>
-          <p:nvPr/>
-        </p:nvSpPr>
-        <p:spPr>
-          <a:xfrm>
-            <a:off x="8339328" y="4434840"/>
-            <a:ext cx="3193999" cy="1828800"/>
-          </a:xfrm>
-          <a:prstGeom prst="rect">
-            <a:avLst/>
-          </a:prstGeom>
-          <a:noFill/>
-        </p:spPr>
-        <p:txBody>
-          <a:bodyPr wrap="square" lIns="0" rIns="0" tIns="0" bIns="0">
-            <a:spAutoFit/>
-          </a:bodyPr>
-          <a:lstStyle/>
-          <a:p>
-            <a:pPr algn="l">
-              <a:lnSpc>
-                <a:spcPct val="130000"/>
-              </a:lnSpc>
-            </a:pPr>
-            <a:r>
-              <a:rPr sz="1100" b="0" i="0">
-                <a:solidFill>
-                  <a:srgbClr val="4A5668"/>
-                </a:solidFill>
-                <a:latin typeface="Segoe UI"/>
-              </a:rPr>
-              <a:t>Net 15 against a Net 30 floor.
-The verdict line is arithmetic rather than a model opinion, the quoted wording shows where it came from, and the replacement sits beside the vendor's original.</a:t>
+              <a:t>Upload, playbook, audit trail and results on one screen, in light or dark.</a:t>
             </a:r>
           </a:p>
         </p:txBody>
@@ -7795,7 +8223,7 @@
       </p:sp>
       <p:pic>
         <p:nvPicPr>
-          <p:cNvPr id="23" name="Picture 22" descr="shot-flagged.png"/>
+          <p:cNvPr id="23" name="Picture 22" descr="new-flagged.png"/>
           <p:cNvPicPr>
             <a:picLocks noChangeAspect="1"/>
           </p:cNvPicPr>
@@ -7810,7 +8238,7 @@
         <p:spPr>
           <a:xfrm>
             <a:off x="658368" y="3858768"/>
-            <a:ext cx="5989320" cy="1491526"/>
+            <a:ext cx="5989320" cy="1682999"/>
           </a:xfrm>
           <a:prstGeom prst="rect">
             <a:avLst/>
@@ -7825,8 +8253,8 @@
         </p:nvSpPr>
         <p:spPr>
           <a:xfrm>
-            <a:off x="658368" y="5440680"/>
-            <a:ext cx="5989320" cy="274320"/>
+            <a:off x="658368" y="5650992"/>
+            <a:ext cx="5989320" cy="365760"/>
           </a:xfrm>
           <a:prstGeom prst="rect">
             <a:avLst/>
@@ -8642,7 +9070,7 @@
                 </a:solidFill>
                 <a:latin typeface="Georgia"/>
               </a:rPr>
-              <a:t>86</a:t>
+              <a:t>132</a:t>
             </a:r>
           </a:p>
         </p:txBody>
@@ -8681,7 +9109,7 @@
                 </a:solidFill>
                 <a:latin typeface="Segoe UI"/>
               </a:rPr>
-              <a:t>tests, 66 needing no API key</a:t>
+              <a:t>tests, 96 needing no API key</a:t>
             </a:r>
           </a:p>
         </p:txBody>

</xml_diff>